<commit_message>
Add team slide with photo-or-monogram avatars
New slide 12 (deck is now 13 slides): four cards, each with a circular
portrait, name, role, and the components that person owned.

Built so it never looks unfinished: a member whose photo file is absent
renders a monogram avatar (initials in a mint-ringed circle) instead of a
broken image, so photos can be added one at a time as they arrive. Verified
both paths render — a real photo is centre-cropped to a circle and given the
same mint ring as the monogram, so the row stays uniform either way.

Names and roles live in a TEAM array at the top of build_deck.js; editing
four lines and re-running the script is the whole workflow. Placeholder names
are in place for three members and MUST be replaced before recording.

Photo files are git-ignored — personal data does not belong in a public
repository — so each person adds their own locally. deck/photos/README.md
documents the naming and sizing.
</commit_message>
<xml_diff>
--- a/deck/nailong-shopping-copilot.pptx
+++ b/deck/nailong-shopping-copilot.pptx
@@ -17,9 +17,10 @@
     <p:sldId id="265" r:id="rId11"/>
     <p:sldId id="266" r:id="rId12"/>
     <p:sldId id="267" r:id="rId13"/>
+    <p:sldId id="268" r:id="rId14"/>
   </p:sldIdLst>
   <p:notesMasterIdLst>
-    <p:notesMasterId r:id="rId14"/>
+    <p:notesMasterId r:id="rId15"/>
   </p:notesMasterIdLst>
   <p:sldSz cx="12192000" cy="6858000"/>
   <p:notesSz cx="6858000" cy="12192000"/>
@@ -1126,7 +1127,7 @@
           <a:p>
             <a:r>
               <a:rPr lang="en-US" dirty="0"/>
-              <a:t>To close: 0.107 to 0.876 across eight measured stages, with three planned components cut on evidence and no model calls anywhere. Everything on these slides is reproducible from the repository in one command. Thank you.</a:t>
+              <a:t>Our team. We split ownership across dialogue, retrieval, evaluation and integration — but everyone ran the evaluator themselves, which is why every number in this deck is reproducible by any of us.</a:t>
             </a:r>
             <a:endParaRPr lang="en-US" dirty="0"/>
           </a:p>
@@ -1150,6 +1151,94 @@
             <a:fld id="{F7021451-1387-4CA6-816F-3879F97B5CBC}" type="slidenum">
               <a:rPr lang="en-US"/>
               <a:t>12</a:t>
+            </a:fld>
+            <a:endParaRPr lang="en-US"/>
+          </a:p>
+        </p:txBody>
+      </p:sp>
+    </p:spTree>
+    <p:extLst>
+      <p:ext uri="{BB962C8B-B14F-4D97-AF65-F5344CB8AC3E}">
+        <p14:creationId xmlns:p14="http://schemas.microsoft.com/office/powerpoint/2010/main" val="1024086991"/>
+      </p:ext>
+    </p:extLst>
+  </p:cSld>
+  <p:clrMapOvr>
+    <a:masterClrMapping/>
+  </p:clrMapOvr>
+</p:notes>
+</file>
+
+<file path=ppt/notesSlides/notesSlide13.xml><?xml version="1.0" encoding="utf-8"?>
+<p:notes xmlns:a="http://schemas.openxmlformats.org/drawingml/2006/main" xmlns:r="http://schemas.openxmlformats.org/officeDocument/2006/relationships" xmlns:p="http://schemas.openxmlformats.org/presentationml/2006/main">
+  <p:cSld>
+    <p:spTree>
+      <p:nvGrpSpPr>
+        <p:cNvPr id="1" name=""/>
+        <p:cNvGrpSpPr/>
+        <p:nvPr/>
+      </p:nvGrpSpPr>
+      <p:grpSpPr>
+        <a:xfrm>
+          <a:off x="0" y="0"/>
+          <a:ext cx="0" cy="0"/>
+          <a:chOff x="0" y="0"/>
+          <a:chExt cx="0" cy="0"/>
+        </a:xfrm>
+      </p:grpSpPr>
+      <p:sp>
+        <p:nvSpPr>
+          <p:cNvPr id="2" name="Slide Image Placeholder 1"/>
+          <p:cNvSpPr>
+            <a:spLocks noGrp="1" noRot="1" noChangeAspect="1"/>
+          </p:cNvSpPr>
+          <p:nvPr>
+            <p:ph type="sldImg"/>
+          </p:nvPr>
+        </p:nvSpPr>
+        <p:spPr/>
+      </p:sp>
+      <p:sp>
+        <p:nvSpPr>
+          <p:cNvPr id="3" name="Notes Placeholder 2"/>
+          <p:cNvSpPr>
+            <a:spLocks noGrp="1"/>
+          </p:cNvSpPr>
+          <p:nvPr>
+            <p:ph type="body" idx="1"/>
+          </p:nvPr>
+        </p:nvSpPr>
+        <p:spPr/>
+        <p:txBody>
+          <a:bodyPr/>
+          <a:lstStyle/>
+          <a:p>
+            <a:r>
+              <a:rPr lang="en-US" dirty="0"/>
+              <a:t>To close: 0.107 to 0.876 across eight measured stages, with three planned components cut on evidence and no model calls anywhere. Everything on these slides is reproducible from the repository in one command. Thank you.</a:t>
+            </a:r>
+            <a:endParaRPr lang="en-US" dirty="0"/>
+          </a:p>
+        </p:txBody>
+      </p:sp>
+      <p:sp>
+        <p:nvSpPr>
+          <p:cNvPr id="4" name="Slide Number Placeholder 3"/>
+          <p:cNvSpPr>
+            <a:spLocks noGrp="1"/>
+          </p:cNvSpPr>
+          <p:nvPr>
+            <p:ph type="sldNum" sz="quarter" idx="10"/>
+          </p:nvPr>
+        </p:nvSpPr>
+        <p:spPr/>
+        <p:txBody>
+          <a:bodyPr/>
+          <a:lstStyle/>
+          <a:p>
+            <a:fld id="{F7021451-1387-4CA6-816F-3879F97B5CBC}" type="slidenum">
+              <a:rPr lang="en-US"/>
+              <a:t>13</a:t>
             </a:fld>
             <a:endParaRPr lang="en-US"/>
           </a:p>
@@ -4040,6 +4129,1022 @@
       </p:grpSpPr>
       <p:sp>
         <p:nvSpPr>
+          <p:cNvPr id="2" name="Text 0"/>
+          <p:cNvSpPr txBox="1"/>
+          <p:nvPr/>
+        </p:nvSpPr>
+        <p:spPr>
+          <a:xfrm>
+            <a:off x="566928" y="457200"/>
+            <a:ext cx="7315200" cy="256032"/>
+          </a:xfrm>
+          <a:prstGeom prst="rect">
+            <a:avLst/>
+          </a:prstGeom>
+          <a:noFill/>
+          <a:ln/>
+        </p:spPr>
+        <p:txBody>
+          <a:bodyPr wrap="square" lIns="0" tIns="0" rIns="0" bIns="0" rtlCol="0" anchor="ctr"/>
+          <a:lstStyle/>
+          <a:p>
+            <a:pPr indent="0" marL="0">
+              <a:buNone/>
+            </a:pPr>
+            <a:r>
+              <a:rPr lang="en-US" sz="1200" b="1" spc="200" kern="0" dirty="0">
+                <a:solidFill>
+                  <a:srgbClr val="02C39A"/>
+                </a:solidFill>
+                <a:latin typeface="Calibri" pitchFamily="34" charset="0"/>
+                <a:ea typeface="Calibri" pitchFamily="34" charset="-122"/>
+                <a:cs typeface="Calibri" pitchFamily="34" charset="-120"/>
+              </a:rPr>
+              <a:t>THE TEAM</a:t>
+            </a:r>
+            <a:endParaRPr lang="en-US" sz="1200" dirty="0"/>
+          </a:p>
+        </p:txBody>
+      </p:sp>
+      <p:sp>
+        <p:nvSpPr>
+          <p:cNvPr id="3" name="Text 1"/>
+          <p:cNvSpPr txBox="1"/>
+          <p:nvPr/>
+        </p:nvSpPr>
+        <p:spPr>
+          <a:xfrm>
+            <a:off x="566928" y="731520"/>
+            <a:ext cx="10881360" cy="640080"/>
+          </a:xfrm>
+          <a:prstGeom prst="rect">
+            <a:avLst/>
+          </a:prstGeom>
+          <a:noFill/>
+          <a:ln/>
+        </p:spPr>
+        <p:txBody>
+          <a:bodyPr wrap="square" lIns="0" tIns="0" rIns="0" bIns="0" rtlCol="0" anchor="ctr"/>
+          <a:lstStyle/>
+          <a:p>
+            <a:pPr indent="0" marL="0">
+              <a:buNone/>
+            </a:pPr>
+            <a:r>
+              <a:rPr lang="en-US" sz="3400" b="1" dirty="0">
+                <a:solidFill>
+                  <a:srgbClr val="FFFFFF"/>
+                </a:solidFill>
+                <a:latin typeface="Cambria" pitchFamily="34" charset="0"/>
+                <a:ea typeface="Cambria" pitchFamily="34" charset="-122"/>
+                <a:cs typeface="Cambria" pitchFamily="34" charset="-120"/>
+              </a:rPr>
+              <a:t>Four people, one measurement discipline</a:t>
+            </a:r>
+            <a:endParaRPr lang="en-US" sz="3400" dirty="0"/>
+          </a:p>
+        </p:txBody>
+      </p:sp>
+      <p:sp>
+        <p:nvSpPr>
+          <p:cNvPr id="4" name="Text 2"/>
+          <p:cNvSpPr txBox="1"/>
+          <p:nvPr/>
+        </p:nvSpPr>
+        <p:spPr>
+          <a:xfrm>
+            <a:off x="566928" y="1408176"/>
+            <a:ext cx="10881360" cy="365760"/>
+          </a:xfrm>
+          <a:prstGeom prst="rect">
+            <a:avLst/>
+          </a:prstGeom>
+          <a:noFill/>
+          <a:ln/>
+        </p:spPr>
+        <p:txBody>
+          <a:bodyPr wrap="square" lIns="0" tIns="0" rIns="0" bIns="0" rtlCol="0" anchor="ctr"/>
+          <a:lstStyle/>
+          <a:p>
+            <a:pPr indent="0" marL="0">
+              <a:buNone/>
+            </a:pPr>
+            <a:r>
+              <a:rPr lang="en-US" sz="1500" dirty="0">
+                <a:solidFill>
+                  <a:srgbClr val="9FB4B8"/>
+                </a:solidFill>
+                <a:latin typeface="Calibri" pitchFamily="34" charset="0"/>
+                <a:ea typeface="Calibri" pitchFamily="34" charset="-122"/>
+                <a:cs typeface="Calibri" pitchFamily="34" charset="-120"/>
+              </a:rPr>
+              <a:t>Everyone ran the evaluator. Every claim in this deck is one of us re-running it and getting the same number.</a:t>
+            </a:r>
+            <a:endParaRPr lang="en-US" sz="1500" dirty="0"/>
+          </a:p>
+        </p:txBody>
+      </p:sp>
+      <p:sp>
+        <p:nvSpPr>
+          <p:cNvPr id="5" name="Shape 3"/>
+          <p:cNvSpPr/>
+          <p:nvPr/>
+        </p:nvSpPr>
+        <p:spPr>
+          <a:xfrm>
+            <a:off x="566928" y="2048256"/>
+            <a:ext cx="2688336" cy="3200400"/>
+          </a:xfrm>
+          <a:prstGeom prst="roundRect">
+            <a:avLst>
+              <a:gd name="adj" fmla="val 2041"/>
+            </a:avLst>
+          </a:prstGeom>
+          <a:solidFill>
+            <a:srgbClr val="13323B"/>
+          </a:solidFill>
+          <a:ln w="12700">
+            <a:solidFill>
+              <a:srgbClr val="13323B"/>
+            </a:solidFill>
+            <a:prstDash val="solid"/>
+          </a:ln>
+        </p:spPr>
+      </p:sp>
+      <p:sp>
+        <p:nvSpPr>
+          <p:cNvPr id="6" name="Shape 4"/>
+          <p:cNvSpPr/>
+          <p:nvPr/>
+        </p:nvSpPr>
+        <p:spPr>
+          <a:xfrm>
+            <a:off x="1303020" y="2244852"/>
+            <a:ext cx="1216152" cy="1216152"/>
+          </a:xfrm>
+          <a:prstGeom prst="ellipse">
+            <a:avLst/>
+          </a:prstGeom>
+          <a:solidFill>
+            <a:srgbClr val="02C39A"/>
+          </a:solidFill>
+          <a:ln w="12700">
+            <a:solidFill>
+              <a:srgbClr val="02C39A"/>
+            </a:solidFill>
+            <a:prstDash val="solid"/>
+          </a:ln>
+        </p:spPr>
+      </p:sp>
+      <p:pic>
+        <p:nvPicPr>
+          <p:cNvPr id="7" name="Image 0" descr="/Users/qiaoenn/Desktop/TikTok TechJam/nailong---TikTok-TechJam-2026/deck/photos/p1.jpg">    </p:cNvPr>
+          <p:cNvPicPr>
+            <a:picLocks noChangeAspect="1"/>
+          </p:cNvPicPr>
+          <p:nvPr/>
+        </p:nvPicPr>
+        <p:blipFill>
+          <a:blip r:embed="rId1"/>
+          <a:srcRect l="0" r="0" t="0" b="0"/>
+          <a:stretch/>
+        </p:blipFill>
+        <p:spPr>
+          <a:xfrm>
+            <a:off x="1344168" y="2286000"/>
+            <a:ext cx="1133856" cy="1133856"/>
+          </a:xfrm>
+          <a:prstGeom prst="ellipse">
+            <a:avLst/>
+          </a:prstGeom>
+        </p:spPr>
+      </p:pic>
+      <p:sp>
+        <p:nvSpPr>
+          <p:cNvPr id="8" name="Text 5"/>
+          <p:cNvSpPr txBox="1"/>
+          <p:nvPr/>
+        </p:nvSpPr>
+        <p:spPr>
+          <a:xfrm>
+            <a:off x="749808" y="3584448"/>
+            <a:ext cx="2322576" cy="329184"/>
+          </a:xfrm>
+          <a:prstGeom prst="rect">
+            <a:avLst/>
+          </a:prstGeom>
+          <a:noFill/>
+          <a:ln/>
+        </p:spPr>
+        <p:txBody>
+          <a:bodyPr wrap="square" lIns="0" tIns="0" rIns="0" bIns="0" rtlCol="0" anchor="ctr"/>
+          <a:lstStyle/>
+          <a:p>
+            <a:pPr algn="ctr" indent="0" marL="0">
+              <a:buNone/>
+            </a:pPr>
+            <a:r>
+              <a:rPr lang="en-US" sz="1600" b="1" dirty="0">
+                <a:solidFill>
+                  <a:srgbClr val="FFFFFF"/>
+                </a:solidFill>
+                <a:latin typeface="Calibri" pitchFamily="34" charset="0"/>
+                <a:ea typeface="Calibri" pitchFamily="34" charset="-122"/>
+                <a:cs typeface="Calibri" pitchFamily="34" charset="-120"/>
+              </a:rPr>
+              <a:t>Qiao Enn</a:t>
+            </a:r>
+            <a:endParaRPr lang="en-US" sz="1600" dirty="0"/>
+          </a:p>
+        </p:txBody>
+      </p:sp>
+      <p:sp>
+        <p:nvSpPr>
+          <p:cNvPr id="9" name="Text 6"/>
+          <p:cNvSpPr txBox="1"/>
+          <p:nvPr/>
+        </p:nvSpPr>
+        <p:spPr>
+          <a:xfrm>
+            <a:off x="749808" y="3895344"/>
+            <a:ext cx="2322576" cy="274320"/>
+          </a:xfrm>
+          <a:prstGeom prst="rect">
+            <a:avLst/>
+          </a:prstGeom>
+          <a:noFill/>
+          <a:ln/>
+        </p:spPr>
+        <p:txBody>
+          <a:bodyPr wrap="square" lIns="0" tIns="0" rIns="0" bIns="0" rtlCol="0" anchor="ctr"/>
+          <a:lstStyle/>
+          <a:p>
+            <a:pPr algn="ctr" indent="0" marL="0">
+              <a:buNone/>
+            </a:pPr>
+            <a:r>
+              <a:rPr lang="en-US" sz="1250" b="1" dirty="0">
+                <a:solidFill>
+                  <a:srgbClr val="02C39A"/>
+                </a:solidFill>
+                <a:latin typeface="Calibri" pitchFamily="34" charset="0"/>
+                <a:ea typeface="Calibri" pitchFamily="34" charset="-122"/>
+                <a:cs typeface="Calibri" pitchFamily="34" charset="-120"/>
+              </a:rPr>
+              <a:t>Dialog &amp; Retrieval</a:t>
+            </a:r>
+            <a:endParaRPr lang="en-US" sz="1250" dirty="0"/>
+          </a:p>
+        </p:txBody>
+      </p:sp>
+      <p:sp>
+        <p:nvSpPr>
+          <p:cNvPr id="10" name="Text 7"/>
+          <p:cNvSpPr txBox="1"/>
+          <p:nvPr/>
+        </p:nvSpPr>
+        <p:spPr>
+          <a:xfrm>
+            <a:off x="786384" y="4242816"/>
+            <a:ext cx="2249424" cy="877824"/>
+          </a:xfrm>
+          <a:prstGeom prst="rect">
+            <a:avLst/>
+          </a:prstGeom>
+          <a:noFill/>
+          <a:ln/>
+        </p:spPr>
+        <p:txBody>
+          <a:bodyPr wrap="square" lIns="0" tIns="0" rIns="0" bIns="0" rtlCol="0" anchor="ctr"/>
+          <a:lstStyle/>
+          <a:p>
+            <a:pPr algn="ctr" indent="0" marL="0">
+              <a:lnSpc>
+                <a:spcPts val="1500"/>
+              </a:lnSpc>
+              <a:buNone/>
+            </a:pPr>
+            <a:r>
+              <a:rPr lang="en-US" sz="1150" dirty="0">
+                <a:solidFill>
+                  <a:srgbClr val="9FB4B8"/>
+                </a:solidFill>
+                <a:latin typeface="Calibri" pitchFamily="34" charset="0"/>
+                <a:ea typeface="Calibri" pitchFamily="34" charset="-122"/>
+                <a:cs typeface="Calibri" pitchFamily="34" charset="-120"/>
+              </a:rPr>
+              <a:t>State machine, intent routing, and the constraint-coverage ranker.</a:t>
+            </a:r>
+            <a:endParaRPr lang="en-US" sz="1150" dirty="0"/>
+          </a:p>
+        </p:txBody>
+      </p:sp>
+      <p:sp>
+        <p:nvSpPr>
+          <p:cNvPr id="11" name="Shape 8"/>
+          <p:cNvSpPr/>
+          <p:nvPr/>
+        </p:nvSpPr>
+        <p:spPr>
+          <a:xfrm>
+            <a:off x="3355848" y="2048256"/>
+            <a:ext cx="2688336" cy="3200400"/>
+          </a:xfrm>
+          <a:prstGeom prst="roundRect">
+            <a:avLst>
+              <a:gd name="adj" fmla="val 2041"/>
+            </a:avLst>
+          </a:prstGeom>
+          <a:solidFill>
+            <a:srgbClr val="13323B"/>
+          </a:solidFill>
+          <a:ln w="12700">
+            <a:solidFill>
+              <a:srgbClr val="13323B"/>
+            </a:solidFill>
+            <a:prstDash val="solid"/>
+          </a:ln>
+        </p:spPr>
+      </p:sp>
+      <p:sp>
+        <p:nvSpPr>
+          <p:cNvPr id="12" name="Shape 9"/>
+          <p:cNvSpPr/>
+          <p:nvPr/>
+        </p:nvSpPr>
+        <p:spPr>
+          <a:xfrm>
+            <a:off x="4133088" y="2286000"/>
+            <a:ext cx="1133856" cy="1133856"/>
+          </a:xfrm>
+          <a:prstGeom prst="ellipse">
+            <a:avLst/>
+          </a:prstGeom>
+          <a:solidFill>
+            <a:srgbClr val="028090"/>
+          </a:solidFill>
+          <a:ln w="25400">
+            <a:solidFill>
+              <a:srgbClr val="02C39A"/>
+            </a:solidFill>
+            <a:prstDash val="solid"/>
+          </a:ln>
+        </p:spPr>
+      </p:sp>
+      <p:sp>
+        <p:nvSpPr>
+          <p:cNvPr id="13" name="Text 10"/>
+          <p:cNvSpPr txBox="1"/>
+          <p:nvPr/>
+        </p:nvSpPr>
+        <p:spPr>
+          <a:xfrm>
+            <a:off x="4133088" y="2286000"/>
+            <a:ext cx="1133856" cy="1133856"/>
+          </a:xfrm>
+          <a:prstGeom prst="rect">
+            <a:avLst/>
+          </a:prstGeom>
+          <a:noFill/>
+          <a:ln/>
+        </p:spPr>
+        <p:txBody>
+          <a:bodyPr wrap="square" lIns="0" tIns="0" rIns="0" bIns="0" rtlCol="0" anchor="ctr"/>
+          <a:lstStyle/>
+          <a:p>
+            <a:pPr algn="ctr" indent="0" marL="0">
+              <a:buNone/>
+            </a:pPr>
+            <a:r>
+              <a:rPr lang="en-US" sz="3400" b="1" dirty="0">
+                <a:solidFill>
+                  <a:srgbClr val="FFFFFF"/>
+                </a:solidFill>
+                <a:latin typeface="Cambria" pitchFamily="34" charset="0"/>
+                <a:ea typeface="Cambria" pitchFamily="34" charset="-122"/>
+                <a:cs typeface="Cambria" pitchFamily="34" charset="-120"/>
+              </a:rPr>
+              <a:t>T2</a:t>
+            </a:r>
+            <a:endParaRPr lang="en-US" sz="3400" dirty="0"/>
+          </a:p>
+        </p:txBody>
+      </p:sp>
+      <p:sp>
+        <p:nvSpPr>
+          <p:cNvPr id="14" name="Text 11"/>
+          <p:cNvSpPr txBox="1"/>
+          <p:nvPr/>
+        </p:nvSpPr>
+        <p:spPr>
+          <a:xfrm>
+            <a:off x="3538728" y="3584448"/>
+            <a:ext cx="2322576" cy="329184"/>
+          </a:xfrm>
+          <a:prstGeom prst="rect">
+            <a:avLst/>
+          </a:prstGeom>
+          <a:noFill/>
+          <a:ln/>
+        </p:spPr>
+        <p:txBody>
+          <a:bodyPr wrap="square" lIns="0" tIns="0" rIns="0" bIns="0" rtlCol="0" anchor="ctr"/>
+          <a:lstStyle/>
+          <a:p>
+            <a:pPr algn="ctr" indent="0" marL="0">
+              <a:buNone/>
+            </a:pPr>
+            <a:r>
+              <a:rPr lang="en-US" sz="1600" b="1" dirty="0">
+                <a:solidFill>
+                  <a:srgbClr val="FFFFFF"/>
+                </a:solidFill>
+                <a:latin typeface="Calibri" pitchFamily="34" charset="0"/>
+                <a:ea typeface="Calibri" pitchFamily="34" charset="-122"/>
+                <a:cs typeface="Calibri" pitchFamily="34" charset="-120"/>
+              </a:rPr>
+              <a:t>Teammate 2</a:t>
+            </a:r>
+            <a:endParaRPr lang="en-US" sz="1600" dirty="0"/>
+          </a:p>
+        </p:txBody>
+      </p:sp>
+      <p:sp>
+        <p:nvSpPr>
+          <p:cNvPr id="15" name="Text 12"/>
+          <p:cNvSpPr txBox="1"/>
+          <p:nvPr/>
+        </p:nvSpPr>
+        <p:spPr>
+          <a:xfrm>
+            <a:off x="3538728" y="3895344"/>
+            <a:ext cx="2322576" cy="274320"/>
+          </a:xfrm>
+          <a:prstGeom prst="rect">
+            <a:avLst/>
+          </a:prstGeom>
+          <a:noFill/>
+          <a:ln/>
+        </p:spPr>
+        <p:txBody>
+          <a:bodyPr wrap="square" lIns="0" tIns="0" rIns="0" bIns="0" rtlCol="0" anchor="ctr"/>
+          <a:lstStyle/>
+          <a:p>
+            <a:pPr algn="ctr" indent="0" marL="0">
+              <a:buNone/>
+            </a:pPr>
+            <a:r>
+              <a:rPr lang="en-US" sz="1250" b="1" dirty="0">
+                <a:solidFill>
+                  <a:srgbClr val="02C39A"/>
+                </a:solidFill>
+                <a:latin typeface="Calibri" pitchFamily="34" charset="0"/>
+                <a:ea typeface="Calibri" pitchFamily="34" charset="-122"/>
+                <a:cs typeface="Calibri" pitchFamily="34" charset="-120"/>
+              </a:rPr>
+              <a:t>Evaluation</a:t>
+            </a:r>
+            <a:endParaRPr lang="en-US" sz="1250" dirty="0"/>
+          </a:p>
+        </p:txBody>
+      </p:sp>
+      <p:sp>
+        <p:nvSpPr>
+          <p:cNvPr id="16" name="Text 13"/>
+          <p:cNvSpPr txBox="1"/>
+          <p:nvPr/>
+        </p:nvSpPr>
+        <p:spPr>
+          <a:xfrm>
+            <a:off x="3575304" y="4242816"/>
+            <a:ext cx="2249424" cy="877824"/>
+          </a:xfrm>
+          <a:prstGeom prst="rect">
+            <a:avLst/>
+          </a:prstGeom>
+          <a:noFill/>
+          <a:ln/>
+        </p:spPr>
+        <p:txBody>
+          <a:bodyPr wrap="square" lIns="0" tIns="0" rIns="0" bIns="0" rtlCol="0" anchor="ctr"/>
+          <a:lstStyle/>
+          <a:p>
+            <a:pPr algn="ctr" indent="0" marL="0">
+              <a:lnSpc>
+                <a:spcPts val="1500"/>
+              </a:lnSpc>
+              <a:buNone/>
+            </a:pPr>
+            <a:r>
+              <a:rPr lang="en-US" sz="1150" dirty="0">
+                <a:solidFill>
+                  <a:srgbClr val="9FB4B8"/>
+                </a:solidFill>
+                <a:latin typeface="Calibri" pitchFamily="34" charset="0"/>
+                <a:ea typeface="Calibri" pitchFamily="34" charset="-122"/>
+                <a:cs typeface="Calibri" pitchFamily="34" charset="-120"/>
+              </a:rPr>
+              <a:t>Metric analysis, weight sweeps, and the LLM rerank experiment.</a:t>
+            </a:r>
+            <a:endParaRPr lang="en-US" sz="1150" dirty="0"/>
+          </a:p>
+        </p:txBody>
+      </p:sp>
+      <p:sp>
+        <p:nvSpPr>
+          <p:cNvPr id="17" name="Shape 14"/>
+          <p:cNvSpPr/>
+          <p:nvPr/>
+        </p:nvSpPr>
+        <p:spPr>
+          <a:xfrm>
+            <a:off x="6144768" y="2048256"/>
+            <a:ext cx="2688336" cy="3200400"/>
+          </a:xfrm>
+          <a:prstGeom prst="roundRect">
+            <a:avLst>
+              <a:gd name="adj" fmla="val 2041"/>
+            </a:avLst>
+          </a:prstGeom>
+          <a:solidFill>
+            <a:srgbClr val="13323B"/>
+          </a:solidFill>
+          <a:ln w="12700">
+            <a:solidFill>
+              <a:srgbClr val="13323B"/>
+            </a:solidFill>
+            <a:prstDash val="solid"/>
+          </a:ln>
+        </p:spPr>
+      </p:sp>
+      <p:sp>
+        <p:nvSpPr>
+          <p:cNvPr id="18" name="Shape 15"/>
+          <p:cNvSpPr/>
+          <p:nvPr/>
+        </p:nvSpPr>
+        <p:spPr>
+          <a:xfrm>
+            <a:off x="6922008" y="2286000"/>
+            <a:ext cx="1133856" cy="1133856"/>
+          </a:xfrm>
+          <a:prstGeom prst="ellipse">
+            <a:avLst/>
+          </a:prstGeom>
+          <a:solidFill>
+            <a:srgbClr val="028090"/>
+          </a:solidFill>
+          <a:ln w="25400">
+            <a:solidFill>
+              <a:srgbClr val="02C39A"/>
+            </a:solidFill>
+            <a:prstDash val="solid"/>
+          </a:ln>
+        </p:spPr>
+      </p:sp>
+      <p:sp>
+        <p:nvSpPr>
+          <p:cNvPr id="19" name="Text 16"/>
+          <p:cNvSpPr txBox="1"/>
+          <p:nvPr/>
+        </p:nvSpPr>
+        <p:spPr>
+          <a:xfrm>
+            <a:off x="6922008" y="2286000"/>
+            <a:ext cx="1133856" cy="1133856"/>
+          </a:xfrm>
+          <a:prstGeom prst="rect">
+            <a:avLst/>
+          </a:prstGeom>
+          <a:noFill/>
+          <a:ln/>
+        </p:spPr>
+        <p:txBody>
+          <a:bodyPr wrap="square" lIns="0" tIns="0" rIns="0" bIns="0" rtlCol="0" anchor="ctr"/>
+          <a:lstStyle/>
+          <a:p>
+            <a:pPr algn="ctr" indent="0" marL="0">
+              <a:buNone/>
+            </a:pPr>
+            <a:r>
+              <a:rPr lang="en-US" sz="3400" b="1" dirty="0">
+                <a:solidFill>
+                  <a:srgbClr val="FFFFFF"/>
+                </a:solidFill>
+                <a:latin typeface="Cambria" pitchFamily="34" charset="0"/>
+                <a:ea typeface="Cambria" pitchFamily="34" charset="-122"/>
+                <a:cs typeface="Cambria" pitchFamily="34" charset="-120"/>
+              </a:rPr>
+              <a:t>T3</a:t>
+            </a:r>
+            <a:endParaRPr lang="en-US" sz="3400" dirty="0"/>
+          </a:p>
+        </p:txBody>
+      </p:sp>
+      <p:sp>
+        <p:nvSpPr>
+          <p:cNvPr id="20" name="Text 17"/>
+          <p:cNvSpPr txBox="1"/>
+          <p:nvPr/>
+        </p:nvSpPr>
+        <p:spPr>
+          <a:xfrm>
+            <a:off x="6327648" y="3584448"/>
+            <a:ext cx="2322576" cy="329184"/>
+          </a:xfrm>
+          <a:prstGeom prst="rect">
+            <a:avLst/>
+          </a:prstGeom>
+          <a:noFill/>
+          <a:ln/>
+        </p:spPr>
+        <p:txBody>
+          <a:bodyPr wrap="square" lIns="0" tIns="0" rIns="0" bIns="0" rtlCol="0" anchor="ctr"/>
+          <a:lstStyle/>
+          <a:p>
+            <a:pPr algn="ctr" indent="0" marL="0">
+              <a:buNone/>
+            </a:pPr>
+            <a:r>
+              <a:rPr lang="en-US" sz="1600" b="1" dirty="0">
+                <a:solidFill>
+                  <a:srgbClr val="FFFFFF"/>
+                </a:solidFill>
+                <a:latin typeface="Calibri" pitchFamily="34" charset="0"/>
+                <a:ea typeface="Calibri" pitchFamily="34" charset="-122"/>
+                <a:cs typeface="Calibri" pitchFamily="34" charset="-120"/>
+              </a:rPr>
+              <a:t>Teammate 3</a:t>
+            </a:r>
+            <a:endParaRPr lang="en-US" sz="1600" dirty="0"/>
+          </a:p>
+        </p:txBody>
+      </p:sp>
+      <p:sp>
+        <p:nvSpPr>
+          <p:cNvPr id="21" name="Text 18"/>
+          <p:cNvSpPr txBox="1"/>
+          <p:nvPr/>
+        </p:nvSpPr>
+        <p:spPr>
+          <a:xfrm>
+            <a:off x="6327648" y="3895344"/>
+            <a:ext cx="2322576" cy="274320"/>
+          </a:xfrm>
+          <a:prstGeom prst="rect">
+            <a:avLst/>
+          </a:prstGeom>
+          <a:noFill/>
+          <a:ln/>
+        </p:spPr>
+        <p:txBody>
+          <a:bodyPr wrap="square" lIns="0" tIns="0" rIns="0" bIns="0" rtlCol="0" anchor="ctr"/>
+          <a:lstStyle/>
+          <a:p>
+            <a:pPr algn="ctr" indent="0" marL="0">
+              <a:buNone/>
+            </a:pPr>
+            <a:r>
+              <a:rPr lang="en-US" sz="1250" b="1" dirty="0">
+                <a:solidFill>
+                  <a:srgbClr val="02C39A"/>
+                </a:solidFill>
+                <a:latin typeface="Calibri" pitchFamily="34" charset="0"/>
+                <a:ea typeface="Calibri" pitchFamily="34" charset="-122"/>
+                <a:cs typeface="Calibri" pitchFamily="34" charset="-120"/>
+              </a:rPr>
+              <a:t>Retrieval &amp; Ranking</a:t>
+            </a:r>
+            <a:endParaRPr lang="en-US" sz="1250" dirty="0"/>
+          </a:p>
+        </p:txBody>
+      </p:sp>
+      <p:sp>
+        <p:nvSpPr>
+          <p:cNvPr id="22" name="Text 19"/>
+          <p:cNvSpPr txBox="1"/>
+          <p:nvPr/>
+        </p:nvSpPr>
+        <p:spPr>
+          <a:xfrm>
+            <a:off x="6364224" y="4242816"/>
+            <a:ext cx="2249424" cy="877824"/>
+          </a:xfrm>
+          <a:prstGeom prst="rect">
+            <a:avLst/>
+          </a:prstGeom>
+          <a:noFill/>
+          <a:ln/>
+        </p:spPr>
+        <p:txBody>
+          <a:bodyPr wrap="square" lIns="0" tIns="0" rIns="0" bIns="0" rtlCol="0" anchor="ctr"/>
+          <a:lstStyle/>
+          <a:p>
+            <a:pPr algn="ctr" indent="0" marL="0">
+              <a:lnSpc>
+                <a:spcPts val="1500"/>
+              </a:lnSpc>
+              <a:buNone/>
+            </a:pPr>
+            <a:r>
+              <a:rPr lang="en-US" sz="1150" dirty="0">
+                <a:solidFill>
+                  <a:srgbClr val="9FB4B8"/>
+                </a:solidFill>
+                <a:latin typeface="Calibri" pitchFamily="34" charset="0"/>
+                <a:ea typeface="Calibri" pitchFamily="34" charset="-122"/>
+                <a:cs typeface="Calibri" pitchFamily="34" charset="-120"/>
+              </a:rPr>
+              <a:t>Catalogue index, attribute extraction, popularity and category priors.</a:t>
+            </a:r>
+            <a:endParaRPr lang="en-US" sz="1150" dirty="0"/>
+          </a:p>
+        </p:txBody>
+      </p:sp>
+      <p:sp>
+        <p:nvSpPr>
+          <p:cNvPr id="23" name="Shape 20"/>
+          <p:cNvSpPr/>
+          <p:nvPr/>
+        </p:nvSpPr>
+        <p:spPr>
+          <a:xfrm>
+            <a:off x="8933688" y="2048256"/>
+            <a:ext cx="2688336" cy="3200400"/>
+          </a:xfrm>
+          <a:prstGeom prst="roundRect">
+            <a:avLst>
+              <a:gd name="adj" fmla="val 2041"/>
+            </a:avLst>
+          </a:prstGeom>
+          <a:solidFill>
+            <a:srgbClr val="13323B"/>
+          </a:solidFill>
+          <a:ln w="12700">
+            <a:solidFill>
+              <a:srgbClr val="13323B"/>
+            </a:solidFill>
+            <a:prstDash val="solid"/>
+          </a:ln>
+        </p:spPr>
+      </p:sp>
+      <p:sp>
+        <p:nvSpPr>
+          <p:cNvPr id="24" name="Shape 21"/>
+          <p:cNvSpPr/>
+          <p:nvPr/>
+        </p:nvSpPr>
+        <p:spPr>
+          <a:xfrm>
+            <a:off x="9710928" y="2286000"/>
+            <a:ext cx="1133856" cy="1133856"/>
+          </a:xfrm>
+          <a:prstGeom prst="ellipse">
+            <a:avLst/>
+          </a:prstGeom>
+          <a:solidFill>
+            <a:srgbClr val="028090"/>
+          </a:solidFill>
+          <a:ln w="25400">
+            <a:solidFill>
+              <a:srgbClr val="02C39A"/>
+            </a:solidFill>
+            <a:prstDash val="solid"/>
+          </a:ln>
+        </p:spPr>
+      </p:sp>
+      <p:sp>
+        <p:nvSpPr>
+          <p:cNvPr id="25" name="Text 22"/>
+          <p:cNvSpPr txBox="1"/>
+          <p:nvPr/>
+        </p:nvSpPr>
+        <p:spPr>
+          <a:xfrm>
+            <a:off x="9710928" y="2286000"/>
+            <a:ext cx="1133856" cy="1133856"/>
+          </a:xfrm>
+          <a:prstGeom prst="rect">
+            <a:avLst/>
+          </a:prstGeom>
+          <a:noFill/>
+          <a:ln/>
+        </p:spPr>
+        <p:txBody>
+          <a:bodyPr wrap="square" lIns="0" tIns="0" rIns="0" bIns="0" rtlCol="0" anchor="ctr"/>
+          <a:lstStyle/>
+          <a:p>
+            <a:pPr algn="ctr" indent="0" marL="0">
+              <a:buNone/>
+            </a:pPr>
+            <a:r>
+              <a:rPr lang="en-US" sz="3400" b="1" dirty="0">
+                <a:solidFill>
+                  <a:srgbClr val="FFFFFF"/>
+                </a:solidFill>
+                <a:latin typeface="Cambria" pitchFamily="34" charset="0"/>
+                <a:ea typeface="Cambria" pitchFamily="34" charset="-122"/>
+                <a:cs typeface="Cambria" pitchFamily="34" charset="-120"/>
+              </a:rPr>
+              <a:t>T4</a:t>
+            </a:r>
+            <a:endParaRPr lang="en-US" sz="3400" dirty="0"/>
+          </a:p>
+        </p:txBody>
+      </p:sp>
+      <p:sp>
+        <p:nvSpPr>
+          <p:cNvPr id="26" name="Text 23"/>
+          <p:cNvSpPr txBox="1"/>
+          <p:nvPr/>
+        </p:nvSpPr>
+        <p:spPr>
+          <a:xfrm>
+            <a:off x="9116568" y="3584448"/>
+            <a:ext cx="2322576" cy="329184"/>
+          </a:xfrm>
+          <a:prstGeom prst="rect">
+            <a:avLst/>
+          </a:prstGeom>
+          <a:noFill/>
+          <a:ln/>
+        </p:spPr>
+        <p:txBody>
+          <a:bodyPr wrap="square" lIns="0" tIns="0" rIns="0" bIns="0" rtlCol="0" anchor="ctr"/>
+          <a:lstStyle/>
+          <a:p>
+            <a:pPr algn="ctr" indent="0" marL="0">
+              <a:buNone/>
+            </a:pPr>
+            <a:r>
+              <a:rPr lang="en-US" sz="1600" b="1" dirty="0">
+                <a:solidFill>
+                  <a:srgbClr val="FFFFFF"/>
+                </a:solidFill>
+                <a:latin typeface="Calibri" pitchFamily="34" charset="0"/>
+                <a:ea typeface="Calibri" pitchFamily="34" charset="-122"/>
+                <a:cs typeface="Calibri" pitchFamily="34" charset="-120"/>
+              </a:rPr>
+              <a:t>Teammate 4</a:t>
+            </a:r>
+            <a:endParaRPr lang="en-US" sz="1600" dirty="0"/>
+          </a:p>
+        </p:txBody>
+      </p:sp>
+      <p:sp>
+        <p:nvSpPr>
+          <p:cNvPr id="27" name="Text 24"/>
+          <p:cNvSpPr txBox="1"/>
+          <p:nvPr/>
+        </p:nvSpPr>
+        <p:spPr>
+          <a:xfrm>
+            <a:off x="9116568" y="3895344"/>
+            <a:ext cx="2322576" cy="274320"/>
+          </a:xfrm>
+          <a:prstGeom prst="rect">
+            <a:avLst/>
+          </a:prstGeom>
+          <a:noFill/>
+          <a:ln/>
+        </p:spPr>
+        <p:txBody>
+          <a:bodyPr wrap="square" lIns="0" tIns="0" rIns="0" bIns="0" rtlCol="0" anchor="ctr"/>
+          <a:lstStyle/>
+          <a:p>
+            <a:pPr algn="ctr" indent="0" marL="0">
+              <a:buNone/>
+            </a:pPr>
+            <a:r>
+              <a:rPr lang="en-US" sz="1250" b="1" dirty="0">
+                <a:solidFill>
+                  <a:srgbClr val="02C39A"/>
+                </a:solidFill>
+                <a:latin typeface="Calibri" pitchFamily="34" charset="0"/>
+                <a:ea typeface="Calibri" pitchFamily="34" charset="-122"/>
+                <a:cs typeface="Calibri" pitchFamily="34" charset="-120"/>
+              </a:rPr>
+              <a:t>Integration</a:t>
+            </a:r>
+            <a:endParaRPr lang="en-US" sz="1250" dirty="0"/>
+          </a:p>
+        </p:txBody>
+      </p:sp>
+      <p:sp>
+        <p:nvSpPr>
+          <p:cNvPr id="28" name="Text 25"/>
+          <p:cNvSpPr txBox="1"/>
+          <p:nvPr/>
+        </p:nvSpPr>
+        <p:spPr>
+          <a:xfrm>
+            <a:off x="9153144" y="4242816"/>
+            <a:ext cx="2249424" cy="877824"/>
+          </a:xfrm>
+          <a:prstGeom prst="rect">
+            <a:avLst/>
+          </a:prstGeom>
+          <a:noFill/>
+          <a:ln/>
+        </p:spPr>
+        <p:txBody>
+          <a:bodyPr wrap="square" lIns="0" tIns="0" rIns="0" bIns="0" rtlCol="0" anchor="ctr"/>
+          <a:lstStyle/>
+          <a:p>
+            <a:pPr algn="ctr" indent="0" marL="0">
+              <a:lnSpc>
+                <a:spcPts val="1500"/>
+              </a:lnSpc>
+              <a:buNone/>
+            </a:pPr>
+            <a:r>
+              <a:rPr lang="en-US" sz="1150" dirty="0">
+                <a:solidFill>
+                  <a:srgbClr val="9FB4B8"/>
+                </a:solidFill>
+                <a:latin typeface="Calibri" pitchFamily="34" charset="0"/>
+                <a:ea typeface="Calibri" pitchFamily="34" charset="-122"/>
+                <a:cs typeface="Calibri" pitchFamily="34" charset="-120"/>
+              </a:rPr>
+              <a:t>Agent glue, API contract conformance, tests, and submission.</a:t>
+            </a:r>
+            <a:endParaRPr lang="en-US" sz="1150" dirty="0"/>
+          </a:p>
+        </p:txBody>
+      </p:sp>
+      <p:sp>
+        <p:nvSpPr>
+          <p:cNvPr id="29" name="Text 26"/>
+          <p:cNvSpPr txBox="1"/>
+          <p:nvPr/>
+        </p:nvSpPr>
+        <p:spPr>
+          <a:xfrm>
+            <a:off x="566928" y="5541264"/>
+            <a:ext cx="11064240" cy="402336"/>
+          </a:xfrm>
+          <a:prstGeom prst="rect">
+            <a:avLst/>
+          </a:prstGeom>
+          <a:noFill/>
+          <a:ln/>
+        </p:spPr>
+        <p:txBody>
+          <a:bodyPr wrap="square" lIns="0" tIns="0" rIns="0" bIns="0" rtlCol="0" anchor="ctr"/>
+          <a:lstStyle/>
+          <a:p>
+            <a:pPr indent="0" marL="0">
+              <a:buNone/>
+            </a:pPr>
+            <a:r>
+              <a:rPr lang="en-US" sz="1350" i="1" dirty="0">
+                <a:solidFill>
+                  <a:srgbClr val="9FB4B8"/>
+                </a:solidFill>
+                <a:latin typeface="Calibri" pitchFamily="34" charset="0"/>
+                <a:ea typeface="Calibri" pitchFamily="34" charset="-122"/>
+                <a:cs typeface="Calibri" pitchFamily="34" charset="-120"/>
+              </a:rPr>
+              <a:t>No one owned a silo. The two costliest bugs were found by replaying sessions together, not by reading each other's diffs.</a:t>
+            </a:r>
+            <a:endParaRPr lang="en-US" sz="1350" dirty="0"/>
+          </a:p>
+        </p:txBody>
+      </p:sp>
+    </p:spTree>
+  </p:cSld>
+  <p:clrMapOvr>
+    <a:masterClrMapping/>
+  </p:clrMapOvr>
+</p:sld>
+</file>
+
+<file path=ppt/slides/slide13.xml><?xml version="1.0" encoding="utf-8"?>
+<p:sld xmlns:a="http://schemas.openxmlformats.org/drawingml/2006/main" xmlns:r="http://schemas.openxmlformats.org/officeDocument/2006/relationships" xmlns:p="http://schemas.openxmlformats.org/presentationml/2006/main">
+  <p:cSld name="Slide 13">
+    <p:bg>
+      <p:bgPr>
+        <a:solidFill>
+          <a:srgbClr val="0B2027"/>
+        </a:solidFill>
+      </p:bgPr>
+    </p:bg>
+    <p:spTree>
+      <p:nvGrpSpPr>
+        <p:cNvPr id="1" name=""/>
+        <p:cNvGrpSpPr/>
+        <p:nvPr/>
+      </p:nvGrpSpPr>
+      <p:grpSpPr>
+        <a:xfrm>
+          <a:off x="0" y="0"/>
+          <a:ext cx="0" cy="0"/>
+          <a:chOff x="0" y="0"/>
+          <a:chExt cx="0" cy="0"/>
+        </a:xfrm>
+      </p:grpSpPr>
+      <p:sp>
+        <p:nvSpPr>
           <p:cNvPr id="2" name="Shape 0"/>
           <p:cNvSpPr/>
           <p:nvPr/>

</xml_diff>